<commit_message>
chore: consistent provenance, local-only deployment, leaner UI
- Result and model files now cite the rewritten commit IDs. v2 results
  cite the commit that contains the v2 code. The ID map is removed.
- Remove render.yaml, DEPLOY.md and hosting references; the product runs
  locally in a hardened container.
- UI drops the model-version chip and the v1/v2 section. Noise-robustness
  evidence is described in product terms.
- Refresh API fixtures, screenshots and the deck.

Co-authored-by: Dhruv Sharma <180669400+Spiritsfuse@users.noreply.github.com>
Co-authored-by: Anushika Chauhan <180333817+Anushika06@users.noreply.github.com>
</commit_message>
<xml_diff>
--- a/docs/Pratirup_Presentation.pptx
+++ b/docs/Pratirup_Presentation.pptx
@@ -125,27 +125,27 @@
   <p:extLst>
     <p:ext uri="{521415D9-36F7-43E2-AB2F-B90AF26B5E84}">
       <p14:sectionLst xmlns:p14="http://schemas.microsoft.com/office/powerpoint/2010/main">
-        <p14:section name="Opening" id="{01ccd4fa-d8d2-dbf2-03bb-b2f4ca0f6ba2}">
+        <p14:section name="Opening" id="{d3799939-6c4e-b7ae-3243-bf28d30a81cb}">
           <p14:sldIdLst>
             <p14:sldId id="256"/>
             <p14:sldId id="257"/>
           </p14:sldIdLst>
         </p14:section>
-        <p14:section name="Problem" id="{ea331a30-97e4-303b-d878-128be1a2f9ec}">
+        <p14:section name="Problem" id="{f2e6c315-e8c7-620f-4934-35323dc144af}">
           <p14:sldIdLst>
             <p14:sldId id="258"/>
             <p14:sldId id="259"/>
             <p14:sldId id="260"/>
           </p14:sldIdLst>
         </p14:section>
-        <p14:section name="Solution" id="{3a25caf8-446a-3681-4f7e-3e19b1c9a15d}">
+        <p14:section name="Solution" id="{b4b9d257-5495-a3e8-c45d-bc215b9d504a}">
           <p14:sldIdLst>
             <p14:sldId id="261"/>
             <p14:sldId id="262"/>
             <p14:sldId id="263"/>
           </p14:sldIdLst>
         </p14:section>
-        <p14:section name="Evidence" id="{2b0643ec-1c92-f8a2-c8af-45afe73c4053}">
+        <p14:section name="Evidence" id="{e493628a-a89d-29a2-8499-397f3cfe5e2a}">
           <p14:sldIdLst>
             <p14:sldId id="264"/>
             <p14:sldId id="265"/>
@@ -156,7 +156,7 @@
             <p14:sldId id="270"/>
           </p14:sldIdLst>
         </p14:section>
-        <p14:section name="Product" id="{1cbf5f43-b435-a26f-da74-447e17152f07}">
+        <p14:section name="Product" id="{7868e36b-1e17-c806-4f10-38cfda31d33a}">
           <p14:sldIdLst>
             <p14:sldId id="271"/>
             <p14:sldId id="272"/>

</xml_diff>